<commit_message>
demo login seed_demo + deploy docs + vercel routing
</commit_message>
<xml_diff>
--- a/Blush-Studio-Technical-Deck.pptx
+++ b/Blush-Studio-Technical-Deck.pptx
@@ -5,20 +5,20 @@
     <p:sldMasterId id="2147483648" r:id="rId1"/>
   </p:sldMasterIdLst>
   <p:sldIdLst>
-    <p:sldId id="256" r:id="rId7"/>
-    <p:sldId id="257" r:id="rId8"/>
-    <p:sldId id="258" r:id="rId9"/>
-    <p:sldId id="259" r:id="rId10"/>
-    <p:sldId id="260" r:id="rId11"/>
-    <p:sldId id="261" r:id="rId12"/>
-    <p:sldId id="262" r:id="rId13"/>
-    <p:sldId id="263" r:id="rId14"/>
-    <p:sldId id="264" r:id="rId15"/>
-    <p:sldId id="265" r:id="rId16"/>
-    <p:sldId id="266" r:id="rId17"/>
-    <p:sldId id="267" r:id="rId18"/>
+    <p:sldId id="256" r:id="rId2"/>
+    <p:sldId id="257" r:id="rId3"/>
+    <p:sldId id="258" r:id="rId4"/>
+    <p:sldId id="259" r:id="rId5"/>
+    <p:sldId id="260" r:id="rId6"/>
+    <p:sldId id="261" r:id="rId7"/>
+    <p:sldId id="262" r:id="rId8"/>
+    <p:sldId id="263" r:id="rId9"/>
+    <p:sldId id="264" r:id="rId10"/>
+    <p:sldId id="265" r:id="rId11"/>
+    <p:sldId id="266" r:id="rId12"/>
+    <p:sldId id="267" r:id="rId13"/>
   </p:sldIdLst>
-  <p:sldSz cx="12191695" cy="6858000" type="screen4x3"/>
+  <p:sldSz cx="12192000" cy="6858000"/>
   <p:notesSz cx="6858000" cy="9144000"/>
   <p:defaultTextStyle>
     <a:defPPr>
@@ -115,6 +115,22 @@
       </a:defRPr>
     </a:lvl9pPr>
   </p:defaultTextStyle>
+  <p:extLst>
+    <p:ext uri="{EFAFB233-063F-42B5-8137-9DF3F51BA10A}">
+      <p15:sldGuideLst xmlns:p15="http://schemas.microsoft.com/office/powerpoint/2012/main">
+        <p15:guide id="1" orient="horz" pos="2160">
+          <p15:clr>
+            <a:srgbClr val="A4A3A4"/>
+          </p15:clr>
+        </p15:guide>
+        <p15:guide id="2" pos="2880">
+          <p15:clr>
+            <a:srgbClr val="A4A3A4"/>
+          </p15:clr>
+        </p15:guide>
+      </p15:sldGuideLst>
+    </p:ext>
+  </p:extLst>
 </p:presentation>
 </file>
 
@@ -156,10 +172,9 @@
           <a:lstStyle/>
           <a:p>
             <a:r>
-              <a:rPr lang="en-US" smtClean="0"/>
+              <a:rPr lang="en-US"/>
               <a:t>Click to edit Master title style</a:t>
             </a:r>
-            <a:endParaRPr lang="en-US"/>
           </a:p>
         </p:txBody>
       </p:sp>
@@ -275,10 +290,9 @@
           </a:lstStyle>
           <a:p>
             <a:r>
-              <a:rPr lang="en-US" smtClean="0"/>
+              <a:rPr lang="en-US"/>
               <a:t>Click to edit Master subtitle style</a:t>
             </a:r>
-            <a:endParaRPr lang="en-US"/>
           </a:p>
         </p:txBody>
       </p:sp>
@@ -299,7 +313,7 @@
           <a:p>
             <a:fld id="{5BCAD085-E8A6-8845-BD4E-CB4CCA059FC4}" type="datetimeFigureOut">
               <a:rPr lang="en-US" smtClean="0"/>
-              <a:t>1/27/13</a:t>
+              <a:t>9/24/2026</a:t>
             </a:fld>
             <a:endParaRPr lang="en-US"/>
           </a:p>
@@ -393,10 +407,9 @@
           <a:lstStyle/>
           <a:p>
             <a:r>
-              <a:rPr lang="en-US" smtClean="0"/>
+              <a:rPr lang="en-US"/>
               <a:t>Click to edit Master title style</a:t>
             </a:r>
-            <a:endParaRPr lang="en-US"/>
           </a:p>
         </p:txBody>
       </p:sp>
@@ -417,38 +430,37 @@
           <a:p>
             <a:pPr lvl="0"/>
             <a:r>
-              <a:rPr lang="en-US" smtClean="0"/>
+              <a:rPr lang="en-US"/>
               <a:t>Click to edit Master text styles</a:t>
             </a:r>
           </a:p>
           <a:p>
             <a:pPr lvl="1"/>
             <a:r>
-              <a:rPr lang="en-US" smtClean="0"/>
+              <a:rPr lang="en-US"/>
               <a:t>Second level</a:t>
             </a:r>
           </a:p>
           <a:p>
             <a:pPr lvl="2"/>
             <a:r>
-              <a:rPr lang="en-US" smtClean="0"/>
+              <a:rPr lang="en-US"/>
               <a:t>Third level</a:t>
             </a:r>
           </a:p>
           <a:p>
             <a:pPr lvl="3"/>
             <a:r>
-              <a:rPr lang="en-US" smtClean="0"/>
+              <a:rPr lang="en-US"/>
               <a:t>Fourth level</a:t>
             </a:r>
           </a:p>
           <a:p>
             <a:pPr lvl="4"/>
             <a:r>
-              <a:rPr lang="en-US" smtClean="0"/>
+              <a:rPr lang="en-US"/>
               <a:t>Fifth level</a:t>
             </a:r>
-            <a:endParaRPr lang="en-US"/>
           </a:p>
         </p:txBody>
       </p:sp>
@@ -469,7 +481,7 @@
           <a:p>
             <a:fld id="{5BCAD085-E8A6-8845-BD4E-CB4CCA059FC4}" type="datetimeFigureOut">
               <a:rPr lang="en-US" smtClean="0"/>
-              <a:t>1/27/13</a:t>
+              <a:t>9/24/2026</a:t>
             </a:fld>
             <a:endParaRPr lang="en-US"/>
           </a:p>
@@ -568,10 +580,9 @@
           <a:lstStyle/>
           <a:p>
             <a:r>
-              <a:rPr lang="en-US" smtClean="0"/>
+              <a:rPr lang="en-US"/>
               <a:t>Click to edit Master title style</a:t>
             </a:r>
-            <a:endParaRPr lang="en-US"/>
           </a:p>
         </p:txBody>
       </p:sp>
@@ -597,38 +608,37 @@
           <a:p>
             <a:pPr lvl="0"/>
             <a:r>
-              <a:rPr lang="en-US" smtClean="0"/>
+              <a:rPr lang="en-US"/>
               <a:t>Click to edit Master text styles</a:t>
             </a:r>
           </a:p>
           <a:p>
             <a:pPr lvl="1"/>
             <a:r>
-              <a:rPr lang="en-US" smtClean="0"/>
+              <a:rPr lang="en-US"/>
               <a:t>Second level</a:t>
             </a:r>
           </a:p>
           <a:p>
             <a:pPr lvl="2"/>
             <a:r>
-              <a:rPr lang="en-US" smtClean="0"/>
+              <a:rPr lang="en-US"/>
               <a:t>Third level</a:t>
             </a:r>
           </a:p>
           <a:p>
             <a:pPr lvl="3"/>
             <a:r>
-              <a:rPr lang="en-US" smtClean="0"/>
+              <a:rPr lang="en-US"/>
               <a:t>Fourth level</a:t>
             </a:r>
           </a:p>
           <a:p>
             <a:pPr lvl="4"/>
             <a:r>
-              <a:rPr lang="en-US" smtClean="0"/>
+              <a:rPr lang="en-US"/>
               <a:t>Fifth level</a:t>
             </a:r>
-            <a:endParaRPr lang="en-US"/>
           </a:p>
         </p:txBody>
       </p:sp>
@@ -649,7 +659,7 @@
           <a:p>
             <a:fld id="{5BCAD085-E8A6-8845-BD4E-CB4CCA059FC4}" type="datetimeFigureOut">
               <a:rPr lang="en-US" smtClean="0"/>
-              <a:t>1/27/13</a:t>
+              <a:t>9/24/2026</a:t>
             </a:fld>
             <a:endParaRPr lang="en-US"/>
           </a:p>
@@ -743,10 +753,9 @@
           <a:lstStyle/>
           <a:p>
             <a:r>
-              <a:rPr lang="en-US" smtClean="0"/>
+              <a:rPr lang="en-US"/>
               <a:t>Click to edit Master title style</a:t>
             </a:r>
-            <a:endParaRPr lang="en-US"/>
           </a:p>
         </p:txBody>
       </p:sp>
@@ -767,38 +776,37 @@
           <a:p>
             <a:pPr lvl="0"/>
             <a:r>
-              <a:rPr lang="en-US" smtClean="0"/>
+              <a:rPr lang="en-US"/>
               <a:t>Click to edit Master text styles</a:t>
             </a:r>
           </a:p>
           <a:p>
             <a:pPr lvl="1"/>
             <a:r>
-              <a:rPr lang="en-US" smtClean="0"/>
+              <a:rPr lang="en-US"/>
               <a:t>Second level</a:t>
             </a:r>
           </a:p>
           <a:p>
             <a:pPr lvl="2"/>
             <a:r>
-              <a:rPr lang="en-US" smtClean="0"/>
+              <a:rPr lang="en-US"/>
               <a:t>Third level</a:t>
             </a:r>
           </a:p>
           <a:p>
             <a:pPr lvl="3"/>
             <a:r>
-              <a:rPr lang="en-US" smtClean="0"/>
+              <a:rPr lang="en-US"/>
               <a:t>Fourth level</a:t>
             </a:r>
           </a:p>
           <a:p>
             <a:pPr lvl="4"/>
             <a:r>
-              <a:rPr lang="en-US" smtClean="0"/>
+              <a:rPr lang="en-US"/>
               <a:t>Fifth level</a:t>
             </a:r>
-            <a:endParaRPr lang="en-US"/>
           </a:p>
         </p:txBody>
       </p:sp>
@@ -819,7 +827,7 @@
           <a:p>
             <a:fld id="{5BCAD085-E8A6-8845-BD4E-CB4CCA059FC4}" type="datetimeFigureOut">
               <a:rPr lang="en-US" smtClean="0"/>
-              <a:t>1/27/13</a:t>
+              <a:t>9/24/2026</a:t>
             </a:fld>
             <a:endParaRPr lang="en-US"/>
           </a:p>
@@ -922,10 +930,9 @@
           </a:lstStyle>
           <a:p>
             <a:r>
-              <a:rPr lang="en-US" smtClean="0"/>
+              <a:rPr lang="en-US"/>
               <a:t>Click to edit Master title style</a:t>
             </a:r>
-            <a:endParaRPr lang="en-US"/>
           </a:p>
         </p:txBody>
       </p:sp>
@@ -1042,7 +1049,7 @@
           <a:p>
             <a:pPr lvl="0"/>
             <a:r>
-              <a:rPr lang="en-US" smtClean="0"/>
+              <a:rPr lang="en-US"/>
               <a:t>Click to edit Master text styles</a:t>
             </a:r>
           </a:p>
@@ -1065,7 +1072,7 @@
           <a:p>
             <a:fld id="{5BCAD085-E8A6-8845-BD4E-CB4CCA059FC4}" type="datetimeFigureOut">
               <a:rPr lang="en-US" smtClean="0"/>
-              <a:t>1/27/13</a:t>
+              <a:t>9/24/2026</a:t>
             </a:fld>
             <a:endParaRPr lang="en-US"/>
           </a:p>
@@ -1159,10 +1166,9 @@
           <a:lstStyle/>
           <a:p>
             <a:r>
-              <a:rPr lang="en-US" smtClean="0"/>
+              <a:rPr lang="en-US"/>
               <a:t>Click to edit Master title style</a:t>
             </a:r>
-            <a:endParaRPr lang="en-US"/>
           </a:p>
         </p:txBody>
       </p:sp>
@@ -1216,38 +1222,37 @@
           <a:p>
             <a:pPr lvl="0"/>
             <a:r>
-              <a:rPr lang="en-US" smtClean="0"/>
+              <a:rPr lang="en-US"/>
               <a:t>Click to edit Master text styles</a:t>
             </a:r>
           </a:p>
           <a:p>
             <a:pPr lvl="1"/>
             <a:r>
-              <a:rPr lang="en-US" smtClean="0"/>
+              <a:rPr lang="en-US"/>
               <a:t>Second level</a:t>
             </a:r>
           </a:p>
           <a:p>
             <a:pPr lvl="2"/>
             <a:r>
-              <a:rPr lang="en-US" smtClean="0"/>
+              <a:rPr lang="en-US"/>
               <a:t>Third level</a:t>
             </a:r>
           </a:p>
           <a:p>
             <a:pPr lvl="3"/>
             <a:r>
-              <a:rPr lang="en-US" smtClean="0"/>
+              <a:rPr lang="en-US"/>
               <a:t>Fourth level</a:t>
             </a:r>
           </a:p>
           <a:p>
             <a:pPr lvl="4"/>
             <a:r>
-              <a:rPr lang="en-US" smtClean="0"/>
+              <a:rPr lang="en-US"/>
               <a:t>Fifth level</a:t>
             </a:r>
-            <a:endParaRPr lang="en-US"/>
           </a:p>
         </p:txBody>
       </p:sp>
@@ -1301,38 +1306,37 @@
           <a:p>
             <a:pPr lvl="0"/>
             <a:r>
-              <a:rPr lang="en-US" smtClean="0"/>
+              <a:rPr lang="en-US"/>
               <a:t>Click to edit Master text styles</a:t>
             </a:r>
           </a:p>
           <a:p>
             <a:pPr lvl="1"/>
             <a:r>
-              <a:rPr lang="en-US" smtClean="0"/>
+              <a:rPr lang="en-US"/>
               <a:t>Second level</a:t>
             </a:r>
           </a:p>
           <a:p>
             <a:pPr lvl="2"/>
             <a:r>
-              <a:rPr lang="en-US" smtClean="0"/>
+              <a:rPr lang="en-US"/>
               <a:t>Third level</a:t>
             </a:r>
           </a:p>
           <a:p>
             <a:pPr lvl="3"/>
             <a:r>
-              <a:rPr lang="en-US" smtClean="0"/>
+              <a:rPr lang="en-US"/>
               <a:t>Fourth level</a:t>
             </a:r>
           </a:p>
           <a:p>
             <a:pPr lvl="4"/>
             <a:r>
-              <a:rPr lang="en-US" smtClean="0"/>
+              <a:rPr lang="en-US"/>
               <a:t>Fifth level</a:t>
             </a:r>
-            <a:endParaRPr lang="en-US"/>
           </a:p>
         </p:txBody>
       </p:sp>
@@ -1353,7 +1357,7 @@
           <a:p>
             <a:fld id="{5BCAD085-E8A6-8845-BD4E-CB4CCA059FC4}" type="datetimeFigureOut">
               <a:rPr lang="en-US" smtClean="0"/>
-              <a:t>1/27/13</a:t>
+              <a:t>9/24/2026</a:t>
             </a:fld>
             <a:endParaRPr lang="en-US"/>
           </a:p>
@@ -1451,10 +1455,9 @@
           </a:lstStyle>
           <a:p>
             <a:r>
-              <a:rPr lang="en-US" smtClean="0"/>
+              <a:rPr lang="en-US"/>
               <a:t>Click to edit Master title style</a:t>
             </a:r>
-            <a:endParaRPr lang="en-US"/>
           </a:p>
         </p:txBody>
       </p:sp>
@@ -1517,7 +1520,7 @@
           <a:p>
             <a:pPr lvl="0"/>
             <a:r>
-              <a:rPr lang="en-US" smtClean="0"/>
+              <a:rPr lang="en-US"/>
               <a:t>Click to edit Master text styles</a:t>
             </a:r>
           </a:p>
@@ -1573,38 +1576,37 @@
           <a:p>
             <a:pPr lvl="0"/>
             <a:r>
-              <a:rPr lang="en-US" smtClean="0"/>
+              <a:rPr lang="en-US"/>
               <a:t>Click to edit Master text styles</a:t>
             </a:r>
           </a:p>
           <a:p>
             <a:pPr lvl="1"/>
             <a:r>
-              <a:rPr lang="en-US" smtClean="0"/>
+              <a:rPr lang="en-US"/>
               <a:t>Second level</a:t>
             </a:r>
           </a:p>
           <a:p>
             <a:pPr lvl="2"/>
             <a:r>
-              <a:rPr lang="en-US" smtClean="0"/>
+              <a:rPr lang="en-US"/>
               <a:t>Third level</a:t>
             </a:r>
           </a:p>
           <a:p>
             <a:pPr lvl="3"/>
             <a:r>
-              <a:rPr lang="en-US" smtClean="0"/>
+              <a:rPr lang="en-US"/>
               <a:t>Fourth level</a:t>
             </a:r>
           </a:p>
           <a:p>
             <a:pPr lvl="4"/>
             <a:r>
-              <a:rPr lang="en-US" smtClean="0"/>
+              <a:rPr lang="en-US"/>
               <a:t>Fifth level</a:t>
             </a:r>
-            <a:endParaRPr lang="en-US"/>
           </a:p>
         </p:txBody>
       </p:sp>
@@ -1667,7 +1669,7 @@
           <a:p>
             <a:pPr lvl="0"/>
             <a:r>
-              <a:rPr lang="en-US" smtClean="0"/>
+              <a:rPr lang="en-US"/>
               <a:t>Click to edit Master text styles</a:t>
             </a:r>
           </a:p>
@@ -1723,38 +1725,37 @@
           <a:p>
             <a:pPr lvl="0"/>
             <a:r>
-              <a:rPr lang="en-US" smtClean="0"/>
+              <a:rPr lang="en-US"/>
               <a:t>Click to edit Master text styles</a:t>
             </a:r>
           </a:p>
           <a:p>
             <a:pPr lvl="1"/>
             <a:r>
-              <a:rPr lang="en-US" smtClean="0"/>
+              <a:rPr lang="en-US"/>
               <a:t>Second level</a:t>
             </a:r>
           </a:p>
           <a:p>
             <a:pPr lvl="2"/>
             <a:r>
-              <a:rPr lang="en-US" smtClean="0"/>
+              <a:rPr lang="en-US"/>
               <a:t>Third level</a:t>
             </a:r>
           </a:p>
           <a:p>
             <a:pPr lvl="3"/>
             <a:r>
-              <a:rPr lang="en-US" smtClean="0"/>
+              <a:rPr lang="en-US"/>
               <a:t>Fourth level</a:t>
             </a:r>
           </a:p>
           <a:p>
             <a:pPr lvl="4"/>
             <a:r>
-              <a:rPr lang="en-US" smtClean="0"/>
+              <a:rPr lang="en-US"/>
               <a:t>Fifth level</a:t>
             </a:r>
-            <a:endParaRPr lang="en-US"/>
           </a:p>
         </p:txBody>
       </p:sp>
@@ -1775,7 +1776,7 @@
           <a:p>
             <a:fld id="{5BCAD085-E8A6-8845-BD4E-CB4CCA059FC4}" type="datetimeFigureOut">
               <a:rPr lang="en-US" smtClean="0"/>
-              <a:t>1/27/13</a:t>
+              <a:t>9/24/2026</a:t>
             </a:fld>
             <a:endParaRPr lang="en-US"/>
           </a:p>
@@ -1869,10 +1870,9 @@
           <a:lstStyle/>
           <a:p>
             <a:r>
-              <a:rPr lang="en-US" smtClean="0"/>
+              <a:rPr lang="en-US"/>
               <a:t>Click to edit Master title style</a:t>
             </a:r>
-            <a:endParaRPr lang="en-US"/>
           </a:p>
         </p:txBody>
       </p:sp>
@@ -1893,7 +1893,7 @@
           <a:p>
             <a:fld id="{5BCAD085-E8A6-8845-BD4E-CB4CCA059FC4}" type="datetimeFigureOut">
               <a:rPr lang="en-US" smtClean="0"/>
-              <a:t>1/27/13</a:t>
+              <a:t>9/24/2026</a:t>
             </a:fld>
             <a:endParaRPr lang="en-US"/>
           </a:p>
@@ -1988,7 +1988,7 @@
           <a:p>
             <a:fld id="{5BCAD085-E8A6-8845-BD4E-CB4CCA059FC4}" type="datetimeFigureOut">
               <a:rPr lang="en-US" smtClean="0"/>
-              <a:t>1/27/13</a:t>
+              <a:t>9/24/2026</a:t>
             </a:fld>
             <a:endParaRPr lang="en-US"/>
           </a:p>
@@ -2091,10 +2091,9 @@
           </a:lstStyle>
           <a:p>
             <a:r>
-              <a:rPr lang="en-US" smtClean="0"/>
+              <a:rPr lang="en-US"/>
               <a:t>Click to edit Master title style</a:t>
             </a:r>
-            <a:endParaRPr lang="en-US"/>
           </a:p>
         </p:txBody>
       </p:sp>
@@ -2148,38 +2147,37 @@
           <a:p>
             <a:pPr lvl="0"/>
             <a:r>
-              <a:rPr lang="en-US" smtClean="0"/>
+              <a:rPr lang="en-US"/>
               <a:t>Click to edit Master text styles</a:t>
             </a:r>
           </a:p>
           <a:p>
             <a:pPr lvl="1"/>
             <a:r>
-              <a:rPr lang="en-US" smtClean="0"/>
+              <a:rPr lang="en-US"/>
               <a:t>Second level</a:t>
             </a:r>
           </a:p>
           <a:p>
             <a:pPr lvl="2"/>
             <a:r>
-              <a:rPr lang="en-US" smtClean="0"/>
+              <a:rPr lang="en-US"/>
               <a:t>Third level</a:t>
             </a:r>
           </a:p>
           <a:p>
             <a:pPr lvl="3"/>
             <a:r>
-              <a:rPr lang="en-US" smtClean="0"/>
+              <a:rPr lang="en-US"/>
               <a:t>Fourth level</a:t>
             </a:r>
           </a:p>
           <a:p>
             <a:pPr lvl="4"/>
             <a:r>
-              <a:rPr lang="en-US" smtClean="0"/>
+              <a:rPr lang="en-US"/>
               <a:t>Fifth level</a:t>
             </a:r>
-            <a:endParaRPr lang="en-US"/>
           </a:p>
         </p:txBody>
       </p:sp>
@@ -2242,7 +2240,7 @@
           <a:p>
             <a:pPr lvl="0"/>
             <a:r>
-              <a:rPr lang="en-US" smtClean="0"/>
+              <a:rPr lang="en-US"/>
               <a:t>Click to edit Master text styles</a:t>
             </a:r>
           </a:p>
@@ -2265,7 +2263,7 @@
           <a:p>
             <a:fld id="{5BCAD085-E8A6-8845-BD4E-CB4CCA059FC4}" type="datetimeFigureOut">
               <a:rPr lang="en-US" smtClean="0"/>
-              <a:t>1/27/13</a:t>
+              <a:t>9/24/2026</a:t>
             </a:fld>
             <a:endParaRPr lang="en-US"/>
           </a:p>
@@ -2368,10 +2366,9 @@
           </a:lstStyle>
           <a:p>
             <a:r>
-              <a:rPr lang="en-US" smtClean="0"/>
+              <a:rPr lang="en-US"/>
               <a:t>Click to edit Master title style</a:t>
             </a:r>
-            <a:endParaRPr lang="en-US"/>
           </a:p>
         </p:txBody>
       </p:sp>
@@ -2495,7 +2492,7 @@
           <a:p>
             <a:pPr lvl="0"/>
             <a:r>
-              <a:rPr lang="en-US" smtClean="0"/>
+              <a:rPr lang="en-US"/>
               <a:t>Click to edit Master text styles</a:t>
             </a:r>
           </a:p>
@@ -2518,7 +2515,7 @@
           <a:p>
             <a:fld id="{5BCAD085-E8A6-8845-BD4E-CB4CCA059FC4}" type="datetimeFigureOut">
               <a:rPr lang="en-US" smtClean="0"/>
-              <a:t>1/27/13</a:t>
+              <a:t>9/24/2026</a:t>
             </a:fld>
             <a:endParaRPr lang="en-US"/>
           </a:p>
@@ -2627,10 +2624,9 @@
           <a:lstStyle/>
           <a:p>
             <a:r>
-              <a:rPr lang="en-US" smtClean="0"/>
+              <a:rPr lang="en-US"/>
               <a:t>Click to edit Master title style</a:t>
             </a:r>
-            <a:endParaRPr lang="en-US"/>
           </a:p>
         </p:txBody>
       </p:sp>
@@ -2661,38 +2657,37 @@
           <a:p>
             <a:pPr lvl="0"/>
             <a:r>
-              <a:rPr lang="en-US" smtClean="0"/>
+              <a:rPr lang="en-US"/>
               <a:t>Click to edit Master text styles</a:t>
             </a:r>
           </a:p>
           <a:p>
             <a:pPr lvl="1"/>
             <a:r>
-              <a:rPr lang="en-US" smtClean="0"/>
+              <a:rPr lang="en-US"/>
               <a:t>Second level</a:t>
             </a:r>
           </a:p>
           <a:p>
             <a:pPr lvl="2"/>
             <a:r>
-              <a:rPr lang="en-US" smtClean="0"/>
+              <a:rPr lang="en-US"/>
               <a:t>Third level</a:t>
             </a:r>
           </a:p>
           <a:p>
             <a:pPr lvl="3"/>
             <a:r>
-              <a:rPr lang="en-US" smtClean="0"/>
+              <a:rPr lang="en-US"/>
               <a:t>Fourth level</a:t>
             </a:r>
           </a:p>
           <a:p>
             <a:pPr lvl="4"/>
             <a:r>
-              <a:rPr lang="en-US" smtClean="0"/>
+              <a:rPr lang="en-US"/>
               <a:t>Fifth level</a:t>
             </a:r>
-            <a:endParaRPr lang="en-US"/>
           </a:p>
         </p:txBody>
       </p:sp>
@@ -2731,7 +2726,7 @@
           <a:p>
             <a:fld id="{5BCAD085-E8A6-8845-BD4E-CB4CCA059FC4}" type="datetimeFigureOut">
               <a:rPr lang="en-US" smtClean="0"/>
-              <a:t>1/27/13</a:t>
+              <a:t>9/24/2026</a:t>
             </a:fld>
             <a:endParaRPr lang="en-US"/>
           </a:p>
@@ -3090,7 +3085,7 @@
 </file>
 
 <file path=ppt/slides/slide1.xml><?xml version="1.0" encoding="utf-8"?>
-<p:sld xmlns:a="http://schemas.openxmlformats.org/drawingml/2006/main" xmlns:p="http://schemas.openxmlformats.org/presentationml/2006/main" xmlns:r="http://schemas.openxmlformats.org/officeDocument/2006/relationships">
+<p:sld xmlns:a="http://schemas.openxmlformats.org/drawingml/2006/main" xmlns:r="http://schemas.openxmlformats.org/officeDocument/2006/relationships" xmlns:p="http://schemas.openxmlformats.org/presentationml/2006/main">
   <p:cSld>
     <p:bg>
       <p:bgPr>
@@ -3106,7 +3101,14 @@
         <p:cNvGrpSpPr/>
         <p:nvPr/>
       </p:nvGrpSpPr>
-      <p:grpSpPr/>
+      <p:grpSpPr>
+        <a:xfrm>
+          <a:off x="0" y="0"/>
+          <a:ext cx="0" cy="0"/>
+          <a:chOff x="0" y="0"/>
+          <a:chExt cx="0" cy="0"/>
+        </a:xfrm>
+      </p:grpSpPr>
       <p:sp>
         <p:nvSpPr>
           <p:cNvPr id="2" name="TextBox 1"/>
@@ -3368,7 +3370,7 @@
           </a:fontRef>
         </p:style>
         <p:txBody>
-          <a:bodyPr rtlCol="0" anchor="ctr" wrap="square"/>
+          <a:bodyPr wrap="square" rtlCol="0" anchor="ctr"/>
           <a:lstStyle/>
           <a:p>
             <a:pPr algn="ctr">
@@ -3514,7 +3516,7 @@
 </file>
 
 <file path=ppt/slides/slide10.xml><?xml version="1.0" encoding="utf-8"?>
-<p:sld xmlns:a="http://schemas.openxmlformats.org/drawingml/2006/main" xmlns:p="http://schemas.openxmlformats.org/presentationml/2006/main" xmlns:r="http://schemas.openxmlformats.org/officeDocument/2006/relationships">
+<p:sld xmlns:a="http://schemas.openxmlformats.org/drawingml/2006/main" xmlns:r="http://schemas.openxmlformats.org/officeDocument/2006/relationships" xmlns:p="http://schemas.openxmlformats.org/presentationml/2006/main">
   <p:cSld>
     <p:bg>
       <p:bgPr>
@@ -3530,7 +3532,14 @@
         <p:cNvGrpSpPr/>
         <p:nvPr/>
       </p:nvGrpSpPr>
-      <p:grpSpPr/>
+      <p:grpSpPr>
+        <a:xfrm>
+          <a:off x="0" y="0"/>
+          <a:ext cx="0" cy="0"/>
+          <a:chOff x="0" y="0"/>
+          <a:chExt cx="0" cy="0"/>
+        </a:xfrm>
+      </p:grpSpPr>
       <p:sp>
         <p:nvSpPr>
           <p:cNvPr id="2" name="TextBox 1"/>
@@ -3655,6 +3664,7 @@
           <a:lstStyle/>
           <a:p>
             <a:pPr algn="ctr"/>
+            <a:endParaRPr/>
           </a:p>
         </p:txBody>
       </p:sp>
@@ -3679,7 +3689,9 @@
             <a:spAutoFit/>
           </a:bodyPr>
           <a:lstStyle/>
-          <a:p/>
+          <a:p>
+            <a:endParaRPr/>
+          </a:p>
           <a:p>
             <a:pPr>
               <a:spcBef>
@@ -3767,7 +3779,7 @@
 </file>
 
 <file path=ppt/slides/slide11.xml><?xml version="1.0" encoding="utf-8"?>
-<p:sld xmlns:a="http://schemas.openxmlformats.org/drawingml/2006/main" xmlns:p="http://schemas.openxmlformats.org/presentationml/2006/main" xmlns:r="http://schemas.openxmlformats.org/officeDocument/2006/relationships">
+<p:sld xmlns:a="http://schemas.openxmlformats.org/drawingml/2006/main" xmlns:r="http://schemas.openxmlformats.org/officeDocument/2006/relationships" xmlns:p="http://schemas.openxmlformats.org/presentationml/2006/main">
   <p:cSld>
     <p:bg>
       <p:bgPr>
@@ -3783,7 +3795,14 @@
         <p:cNvGrpSpPr/>
         <p:nvPr/>
       </p:nvGrpSpPr>
-      <p:grpSpPr/>
+      <p:grpSpPr>
+        <a:xfrm>
+          <a:off x="0" y="0"/>
+          <a:ext cx="0" cy="0"/>
+          <a:chOff x="0" y="0"/>
+          <a:chExt cx="0" cy="0"/>
+        </a:xfrm>
+      </p:grpSpPr>
       <p:sp>
         <p:nvSpPr>
           <p:cNvPr id="2" name="TextBox 1"/>
@@ -3908,6 +3927,7 @@
           <a:lstStyle/>
           <a:p>
             <a:pPr algn="ctr"/>
+            <a:endParaRPr/>
           </a:p>
         </p:txBody>
       </p:sp>
@@ -3932,7 +3952,9 @@
             <a:spAutoFit/>
           </a:bodyPr>
           <a:lstStyle/>
-          <a:p/>
+          <a:p>
+            <a:endParaRPr/>
+          </a:p>
           <a:p>
             <a:pPr>
               <a:spcBef>
@@ -4039,7 +4061,7 @@
 </file>
 
 <file path=ppt/slides/slide12.xml><?xml version="1.0" encoding="utf-8"?>
-<p:sld xmlns:a="http://schemas.openxmlformats.org/drawingml/2006/main" xmlns:p="http://schemas.openxmlformats.org/presentationml/2006/main" xmlns:r="http://schemas.openxmlformats.org/officeDocument/2006/relationships">
+<p:sld xmlns:a="http://schemas.openxmlformats.org/drawingml/2006/main" xmlns:r="http://schemas.openxmlformats.org/officeDocument/2006/relationships" xmlns:p="http://schemas.openxmlformats.org/presentationml/2006/main">
   <p:cSld>
     <p:bg>
       <p:bgPr>
@@ -4055,7 +4077,14 @@
         <p:cNvGrpSpPr/>
         <p:nvPr/>
       </p:nvGrpSpPr>
-      <p:grpSpPr/>
+      <p:grpSpPr>
+        <a:xfrm>
+          <a:off x="0" y="0"/>
+          <a:ext cx="0" cy="0"/>
+          <a:chOff x="0" y="0"/>
+          <a:chExt cx="0" cy="0"/>
+        </a:xfrm>
+      </p:grpSpPr>
       <p:sp>
         <p:nvSpPr>
           <p:cNvPr id="2" name="TextBox 1"/>
@@ -4180,6 +4209,7 @@
           <a:lstStyle/>
           <a:p>
             <a:pPr algn="ctr"/>
+            <a:endParaRPr/>
           </a:p>
         </p:txBody>
       </p:sp>
@@ -4204,7 +4234,9 @@
             <a:spAutoFit/>
           </a:bodyPr>
           <a:lstStyle/>
-          <a:p/>
+          <a:p>
+            <a:endParaRPr/>
+          </a:p>
           <a:p>
             <a:pPr>
               <a:spcBef>
@@ -4311,7 +4343,7 @@
 </file>
 
 <file path=ppt/slides/slide2.xml><?xml version="1.0" encoding="utf-8"?>
-<p:sld xmlns:a="http://schemas.openxmlformats.org/drawingml/2006/main" xmlns:p="http://schemas.openxmlformats.org/presentationml/2006/main" xmlns:r="http://schemas.openxmlformats.org/officeDocument/2006/relationships">
+<p:sld xmlns:a="http://schemas.openxmlformats.org/drawingml/2006/main" xmlns:r="http://schemas.openxmlformats.org/officeDocument/2006/relationships" xmlns:p="http://schemas.openxmlformats.org/presentationml/2006/main">
   <p:cSld>
     <p:bg>
       <p:bgPr>
@@ -4327,7 +4359,14 @@
         <p:cNvGrpSpPr/>
         <p:nvPr/>
       </p:nvGrpSpPr>
-      <p:grpSpPr/>
+      <p:grpSpPr>
+        <a:xfrm>
+          <a:off x="0" y="0"/>
+          <a:ext cx="0" cy="0"/>
+          <a:chOff x="0" y="0"/>
+          <a:chExt cx="0" cy="0"/>
+        </a:xfrm>
+      </p:grpSpPr>
       <p:sp>
         <p:nvSpPr>
           <p:cNvPr id="2" name="TextBox 1"/>
@@ -4452,6 +4491,7 @@
           <a:lstStyle/>
           <a:p>
             <a:pPr algn="ctr"/>
+            <a:endParaRPr/>
           </a:p>
         </p:txBody>
       </p:sp>
@@ -4476,7 +4516,9 @@
             <a:spAutoFit/>
           </a:bodyPr>
           <a:lstStyle/>
-          <a:p/>
+          <a:p>
+            <a:endParaRPr/>
+          </a:p>
           <a:p>
             <a:pPr>
               <a:spcBef>
@@ -4583,7 +4625,7 @@
 </file>
 
 <file path=ppt/slides/slide3.xml><?xml version="1.0" encoding="utf-8"?>
-<p:sld xmlns:a="http://schemas.openxmlformats.org/drawingml/2006/main" xmlns:p="http://schemas.openxmlformats.org/presentationml/2006/main" xmlns:r="http://schemas.openxmlformats.org/officeDocument/2006/relationships">
+<p:sld xmlns:a="http://schemas.openxmlformats.org/drawingml/2006/main" xmlns:r="http://schemas.openxmlformats.org/officeDocument/2006/relationships" xmlns:p="http://schemas.openxmlformats.org/presentationml/2006/main">
   <p:cSld>
     <p:bg>
       <p:bgPr>
@@ -4599,7 +4641,14 @@
         <p:cNvGrpSpPr/>
         <p:nvPr/>
       </p:nvGrpSpPr>
-      <p:grpSpPr/>
+      <p:grpSpPr>
+        <a:xfrm>
+          <a:off x="0" y="0"/>
+          <a:ext cx="0" cy="0"/>
+          <a:chOff x="0" y="0"/>
+          <a:chExt cx="0" cy="0"/>
+        </a:xfrm>
+      </p:grpSpPr>
       <p:sp>
         <p:nvSpPr>
           <p:cNvPr id="2" name="TextBox 1"/>
@@ -4724,6 +4773,7 @@
           <a:lstStyle/>
           <a:p>
             <a:pPr algn="ctr"/>
+            <a:endParaRPr/>
           </a:p>
         </p:txBody>
       </p:sp>
@@ -4748,7 +4798,9 @@
             <a:spAutoFit/>
           </a:bodyPr>
           <a:lstStyle/>
-          <a:p/>
+          <a:p>
+            <a:endParaRPr/>
+          </a:p>
           <a:p>
             <a:pPr>
               <a:spcBef>
@@ -4855,7 +4907,7 @@
 </file>
 
 <file path=ppt/slides/slide4.xml><?xml version="1.0" encoding="utf-8"?>
-<p:sld xmlns:a="http://schemas.openxmlformats.org/drawingml/2006/main" xmlns:p="http://schemas.openxmlformats.org/presentationml/2006/main" xmlns:r="http://schemas.openxmlformats.org/officeDocument/2006/relationships">
+<p:sld xmlns:a="http://schemas.openxmlformats.org/drawingml/2006/main" xmlns:r="http://schemas.openxmlformats.org/officeDocument/2006/relationships" xmlns:p="http://schemas.openxmlformats.org/presentationml/2006/main">
   <p:cSld>
     <p:bg>
       <p:bgPr>
@@ -4871,7 +4923,14 @@
         <p:cNvGrpSpPr/>
         <p:nvPr/>
       </p:nvGrpSpPr>
-      <p:grpSpPr/>
+      <p:grpSpPr>
+        <a:xfrm>
+          <a:off x="0" y="0"/>
+          <a:ext cx="0" cy="0"/>
+          <a:chOff x="0" y="0"/>
+          <a:chExt cx="0" cy="0"/>
+        </a:xfrm>
+      </p:grpSpPr>
       <p:sp>
         <p:nvSpPr>
           <p:cNvPr id="2" name="TextBox 1"/>
@@ -4996,6 +5055,7 @@
           <a:lstStyle/>
           <a:p>
             <a:pPr algn="ctr"/>
+            <a:endParaRPr/>
           </a:p>
         </p:txBody>
       </p:sp>
@@ -5020,7 +5080,9 @@
             <a:spAutoFit/>
           </a:bodyPr>
           <a:lstStyle/>
-          <a:p/>
+          <a:p>
+            <a:endParaRPr/>
+          </a:p>
           <a:p>
             <a:pPr>
               <a:spcBef>
@@ -5146,7 +5208,7 @@
 </file>
 
 <file path=ppt/slides/slide5.xml><?xml version="1.0" encoding="utf-8"?>
-<p:sld xmlns:a="http://schemas.openxmlformats.org/drawingml/2006/main" xmlns:p="http://schemas.openxmlformats.org/presentationml/2006/main" xmlns:r="http://schemas.openxmlformats.org/officeDocument/2006/relationships">
+<p:sld xmlns:a="http://schemas.openxmlformats.org/drawingml/2006/main" xmlns:r="http://schemas.openxmlformats.org/officeDocument/2006/relationships" xmlns:p="http://schemas.openxmlformats.org/presentationml/2006/main">
   <p:cSld>
     <p:bg>
       <p:bgPr>
@@ -5162,7 +5224,14 @@
         <p:cNvGrpSpPr/>
         <p:nvPr/>
       </p:nvGrpSpPr>
-      <p:grpSpPr/>
+      <p:grpSpPr>
+        <a:xfrm>
+          <a:off x="0" y="0"/>
+          <a:ext cx="0" cy="0"/>
+          <a:chOff x="0" y="0"/>
+          <a:chExt cx="0" cy="0"/>
+        </a:xfrm>
+      </p:grpSpPr>
       <p:sp>
         <p:nvSpPr>
           <p:cNvPr id="2" name="TextBox 1"/>
@@ -5287,6 +5356,7 @@
           <a:lstStyle/>
           <a:p>
             <a:pPr algn="ctr"/>
+            <a:endParaRPr/>
           </a:p>
         </p:txBody>
       </p:sp>
@@ -5300,7 +5370,7 @@
         </p:nvGraphicFramePr>
         <p:xfrm>
           <a:off x="548640" y="1737360"/>
-          <a:ext cx="4937760" cy="1920240"/>
+          <a:ext cx="4937760" cy="1828800"/>
         </p:xfrm>
         <a:graphic>
           <a:graphicData uri="http://schemas.openxmlformats.org/drawingml/2006/table">
@@ -5309,8 +5379,20 @@
                 <a:tableStyleId>{5C22544A-7EE6-4342-B048-85BDC9FD1C3A}</a:tableStyleId>
               </a:tblPr>
               <a:tblGrid>
-                <a:gridCol w="2194560"/>
-                <a:gridCol w="2743200"/>
+                <a:gridCol w="2194560">
+                  <a:extLst>
+                    <a:ext uri="{9D8B030D-6E8A-4147-A177-3AD203B41FA5}">
+                      <a16:colId xmlns:a16="http://schemas.microsoft.com/office/drawing/2014/main" val="20000"/>
+                    </a:ext>
+                  </a:extLst>
+                </a:gridCol>
+                <a:gridCol w="2743200">
+                  <a:extLst>
+                    <a:ext uri="{9D8B030D-6E8A-4147-A177-3AD203B41FA5}">
+                      <a16:colId xmlns:a16="http://schemas.microsoft.com/office/drawing/2014/main" val="20001"/>
+                    </a:ext>
+                  </a:extLst>
+                </a:gridCol>
               </a:tblGrid>
               <a:tr h="365760">
                 <a:tc>
@@ -5357,6 +5439,11 @@
                     </a:solidFill>
                   </a:tcPr>
                 </a:tc>
+                <a:extLst>
+                  <a:ext uri="{0D108BD9-81ED-4DB2-BD59-A6C34878D82A}">
+                    <a16:rowId xmlns:a16="http://schemas.microsoft.com/office/drawing/2014/main" val="10000"/>
+                  </a:ext>
+                </a:extLst>
               </a:tr>
               <a:tr h="365760">
                 <a:tc>
@@ -5395,6 +5482,11 @@
                   </a:txBody>
                   <a:tcPr/>
                 </a:tc>
+                <a:extLst>
+                  <a:ext uri="{0D108BD9-81ED-4DB2-BD59-A6C34878D82A}">
+                    <a16:rowId xmlns:a16="http://schemas.microsoft.com/office/drawing/2014/main" val="10001"/>
+                  </a:ext>
+                </a:extLst>
               </a:tr>
               <a:tr h="365760">
                 <a:tc>
@@ -5441,6 +5533,11 @@
                     </a:solidFill>
                   </a:tcPr>
                 </a:tc>
+                <a:extLst>
+                  <a:ext uri="{0D108BD9-81ED-4DB2-BD59-A6C34878D82A}">
+                    <a16:rowId xmlns:a16="http://schemas.microsoft.com/office/drawing/2014/main" val="10002"/>
+                  </a:ext>
+                </a:extLst>
               </a:tr>
               <a:tr h="365760">
                 <a:tc>
@@ -5479,6 +5576,11 @@
                   </a:txBody>
                   <a:tcPr/>
                 </a:tc>
+                <a:extLst>
+                  <a:ext uri="{0D108BD9-81ED-4DB2-BD59-A6C34878D82A}">
+                    <a16:rowId xmlns:a16="http://schemas.microsoft.com/office/drawing/2014/main" val="10003"/>
+                  </a:ext>
+                </a:extLst>
               </a:tr>
               <a:tr h="365760">
                 <a:tc>
@@ -5525,6 +5627,11 @@
                     </a:solidFill>
                   </a:tcPr>
                 </a:tc>
+                <a:extLst>
+                  <a:ext uri="{0D108BD9-81ED-4DB2-BD59-A6C34878D82A}">
+                    <a16:rowId xmlns:a16="http://schemas.microsoft.com/office/drawing/2014/main" val="10004"/>
+                  </a:ext>
+                </a:extLst>
               </a:tr>
             </a:tbl>
           </a:graphicData>
@@ -5551,7 +5658,9 @@
             <a:spAutoFit/>
           </a:bodyPr>
           <a:lstStyle/>
-          <a:p/>
+          <a:p>
+            <a:endParaRPr/>
+          </a:p>
           <a:p>
             <a:pPr>
               <a:spcBef>
@@ -5677,7 +5786,7 @@
 </file>
 
 <file path=ppt/slides/slide6.xml><?xml version="1.0" encoding="utf-8"?>
-<p:sld xmlns:a="http://schemas.openxmlformats.org/drawingml/2006/main" xmlns:p="http://schemas.openxmlformats.org/presentationml/2006/main" xmlns:r="http://schemas.openxmlformats.org/officeDocument/2006/relationships">
+<p:sld xmlns:a="http://schemas.openxmlformats.org/drawingml/2006/main" xmlns:r="http://schemas.openxmlformats.org/officeDocument/2006/relationships" xmlns:p="http://schemas.openxmlformats.org/presentationml/2006/main">
   <p:cSld>
     <p:bg>
       <p:bgPr>
@@ -5693,7 +5802,14 @@
         <p:cNvGrpSpPr/>
         <p:nvPr/>
       </p:nvGrpSpPr>
-      <p:grpSpPr/>
+      <p:grpSpPr>
+        <a:xfrm>
+          <a:off x="0" y="0"/>
+          <a:ext cx="0" cy="0"/>
+          <a:chOff x="0" y="0"/>
+          <a:chExt cx="0" cy="0"/>
+        </a:xfrm>
+      </p:grpSpPr>
       <p:sp>
         <p:nvSpPr>
           <p:cNvPr id="2" name="TextBox 1"/>
@@ -5818,6 +5934,7 @@
           <a:lstStyle/>
           <a:p>
             <a:pPr algn="ctr"/>
+            <a:endParaRPr/>
           </a:p>
         </p:txBody>
       </p:sp>
@@ -5842,7 +5959,9 @@
             <a:spAutoFit/>
           </a:bodyPr>
           <a:lstStyle/>
-          <a:p/>
+          <a:p>
+            <a:endParaRPr/>
+          </a:p>
           <a:p>
             <a:pPr>
               <a:spcBef>
@@ -5968,7 +6087,7 @@
 </file>
 
 <file path=ppt/slides/slide7.xml><?xml version="1.0" encoding="utf-8"?>
-<p:sld xmlns:a="http://schemas.openxmlformats.org/drawingml/2006/main" xmlns:p="http://schemas.openxmlformats.org/presentationml/2006/main" xmlns:r="http://schemas.openxmlformats.org/officeDocument/2006/relationships">
+<p:sld xmlns:a="http://schemas.openxmlformats.org/drawingml/2006/main" xmlns:r="http://schemas.openxmlformats.org/officeDocument/2006/relationships" xmlns:p="http://schemas.openxmlformats.org/presentationml/2006/main">
   <p:cSld>
     <p:bg>
       <p:bgPr>
@@ -5984,7 +6103,14 @@
         <p:cNvGrpSpPr/>
         <p:nvPr/>
       </p:nvGrpSpPr>
-      <p:grpSpPr/>
+      <p:grpSpPr>
+        <a:xfrm>
+          <a:off x="0" y="0"/>
+          <a:ext cx="0" cy="0"/>
+          <a:chOff x="0" y="0"/>
+          <a:chExt cx="0" cy="0"/>
+        </a:xfrm>
+      </p:grpSpPr>
       <p:sp>
         <p:nvSpPr>
           <p:cNvPr id="2" name="TextBox 1"/>
@@ -6109,6 +6235,7 @@
           <a:lstStyle/>
           <a:p>
             <a:pPr algn="ctr"/>
+            <a:endParaRPr/>
           </a:p>
         </p:txBody>
       </p:sp>
@@ -6122,7 +6249,7 @@
         </p:nvGraphicFramePr>
         <p:xfrm>
           <a:off x="548640" y="1737360"/>
-          <a:ext cx="11064240" cy="4608576"/>
+          <a:ext cx="11064240" cy="3307080"/>
         </p:xfrm>
         <a:graphic>
           <a:graphicData uri="http://schemas.openxmlformats.org/drawingml/2006/table">
@@ -6131,9 +6258,27 @@
                 <a:tableStyleId>{5C22544A-7EE6-4342-B048-85BDC9FD1C3A}</a:tableStyleId>
               </a:tblPr>
               <a:tblGrid>
-                <a:gridCol w="1188720"/>
-                <a:gridCol w="3291840"/>
-                <a:gridCol w="6583680"/>
+                <a:gridCol w="1188720">
+                  <a:extLst>
+                    <a:ext uri="{9D8B030D-6E8A-4147-A177-3AD203B41FA5}">
+                      <a16:colId xmlns:a16="http://schemas.microsoft.com/office/drawing/2014/main" val="20000"/>
+                    </a:ext>
+                  </a:extLst>
+                </a:gridCol>
+                <a:gridCol w="3291840">
+                  <a:extLst>
+                    <a:ext uri="{9D8B030D-6E8A-4147-A177-3AD203B41FA5}">
+                      <a16:colId xmlns:a16="http://schemas.microsoft.com/office/drawing/2014/main" val="20001"/>
+                    </a:ext>
+                  </a:extLst>
+                </a:gridCol>
+                <a:gridCol w="6583680">
+                  <a:extLst>
+                    <a:ext uri="{9D8B030D-6E8A-4147-A177-3AD203B41FA5}">
+                      <a16:colId xmlns:a16="http://schemas.microsoft.com/office/drawing/2014/main" val="20002"/>
+                    </a:ext>
+                  </a:extLst>
+                </a:gridCol>
               </a:tblGrid>
               <a:tr h="152400">
                 <a:tc>
@@ -6202,6 +6347,11 @@
                     </a:solidFill>
                   </a:tcPr>
                 </a:tc>
+                <a:extLst>
+                  <a:ext uri="{0D108BD9-81ED-4DB2-BD59-A6C34878D82A}">
+                    <a16:rowId xmlns:a16="http://schemas.microsoft.com/office/drawing/2014/main" val="10000"/>
+                  </a:ext>
+                </a:extLst>
               </a:tr>
               <a:tr h="152400">
                 <a:tc>
@@ -6258,6 +6408,11 @@
                   </a:txBody>
                   <a:tcPr/>
                 </a:tc>
+                <a:extLst>
+                  <a:ext uri="{0D108BD9-81ED-4DB2-BD59-A6C34878D82A}">
+                    <a16:rowId xmlns:a16="http://schemas.microsoft.com/office/drawing/2014/main" val="10001"/>
+                  </a:ext>
+                </a:extLst>
               </a:tr>
               <a:tr h="152400">
                 <a:tc>
@@ -6326,6 +6481,11 @@
                     </a:solidFill>
                   </a:tcPr>
                 </a:tc>
+                <a:extLst>
+                  <a:ext uri="{0D108BD9-81ED-4DB2-BD59-A6C34878D82A}">
+                    <a16:rowId xmlns:a16="http://schemas.microsoft.com/office/drawing/2014/main" val="10002"/>
+                  </a:ext>
+                </a:extLst>
               </a:tr>
               <a:tr h="152400">
                 <a:tc>
@@ -6382,6 +6542,11 @@
                   </a:txBody>
                   <a:tcPr/>
                 </a:tc>
+                <a:extLst>
+                  <a:ext uri="{0D108BD9-81ED-4DB2-BD59-A6C34878D82A}">
+                    <a16:rowId xmlns:a16="http://schemas.microsoft.com/office/drawing/2014/main" val="10003"/>
+                  </a:ext>
+                </a:extLst>
               </a:tr>
               <a:tr h="152400">
                 <a:tc>
@@ -6450,6 +6615,11 @@
                     </a:solidFill>
                   </a:tcPr>
                 </a:tc>
+                <a:extLst>
+                  <a:ext uri="{0D108BD9-81ED-4DB2-BD59-A6C34878D82A}">
+                    <a16:rowId xmlns:a16="http://schemas.microsoft.com/office/drawing/2014/main" val="10004"/>
+                  </a:ext>
+                </a:extLst>
               </a:tr>
               <a:tr h="152400">
                 <a:tc>
@@ -6506,6 +6676,11 @@
                   </a:txBody>
                   <a:tcPr/>
                 </a:tc>
+                <a:extLst>
+                  <a:ext uri="{0D108BD9-81ED-4DB2-BD59-A6C34878D82A}">
+                    <a16:rowId xmlns:a16="http://schemas.microsoft.com/office/drawing/2014/main" val="10005"/>
+                  </a:ext>
+                </a:extLst>
               </a:tr>
               <a:tr h="152400">
                 <a:tc>
@@ -6574,6 +6749,11 @@
                     </a:solidFill>
                   </a:tcPr>
                 </a:tc>
+                <a:extLst>
+                  <a:ext uri="{0D108BD9-81ED-4DB2-BD59-A6C34878D82A}">
+                    <a16:rowId xmlns:a16="http://schemas.microsoft.com/office/drawing/2014/main" val="10006"/>
+                  </a:ext>
+                </a:extLst>
               </a:tr>
               <a:tr h="152400">
                 <a:tc>
@@ -6630,6 +6810,11 @@
                   </a:txBody>
                   <a:tcPr/>
                 </a:tc>
+                <a:extLst>
+                  <a:ext uri="{0D108BD9-81ED-4DB2-BD59-A6C34878D82A}">
+                    <a16:rowId xmlns:a16="http://schemas.microsoft.com/office/drawing/2014/main" val="10007"/>
+                  </a:ext>
+                </a:extLst>
               </a:tr>
               <a:tr h="152400">
                 <a:tc>
@@ -6698,6 +6883,11 @@
                     </a:solidFill>
                   </a:tcPr>
                 </a:tc>
+                <a:extLst>
+                  <a:ext uri="{0D108BD9-81ED-4DB2-BD59-A6C34878D82A}">
+                    <a16:rowId xmlns:a16="http://schemas.microsoft.com/office/drawing/2014/main" val="10008"/>
+                  </a:ext>
+                </a:extLst>
               </a:tr>
               <a:tr h="152400">
                 <a:tc>
@@ -6754,6 +6944,11 @@
                   </a:txBody>
                   <a:tcPr/>
                 </a:tc>
+                <a:extLst>
+                  <a:ext uri="{0D108BD9-81ED-4DB2-BD59-A6C34878D82A}">
+                    <a16:rowId xmlns:a16="http://schemas.microsoft.com/office/drawing/2014/main" val="10009"/>
+                  </a:ext>
+                </a:extLst>
               </a:tr>
               <a:tr h="152400">
                 <a:tc>
@@ -6822,6 +7017,11 @@
                     </a:solidFill>
                   </a:tcPr>
                 </a:tc>
+                <a:extLst>
+                  <a:ext uri="{0D108BD9-81ED-4DB2-BD59-A6C34878D82A}">
+                    <a16:rowId xmlns:a16="http://schemas.microsoft.com/office/drawing/2014/main" val="10010"/>
+                  </a:ext>
+                </a:extLst>
               </a:tr>
               <a:tr h="152400">
                 <a:tc>
@@ -6878,6 +7078,11 @@
                   </a:txBody>
                   <a:tcPr/>
                 </a:tc>
+                <a:extLst>
+                  <a:ext uri="{0D108BD9-81ED-4DB2-BD59-A6C34878D82A}">
+                    <a16:rowId xmlns:a16="http://schemas.microsoft.com/office/drawing/2014/main" val="10011"/>
+                  </a:ext>
+                </a:extLst>
               </a:tr>
             </a:tbl>
           </a:graphicData>
@@ -6892,7 +7097,7 @@
 </file>
 
 <file path=ppt/slides/slide8.xml><?xml version="1.0" encoding="utf-8"?>
-<p:sld xmlns:a="http://schemas.openxmlformats.org/drawingml/2006/main" xmlns:p="http://schemas.openxmlformats.org/presentationml/2006/main" xmlns:r="http://schemas.openxmlformats.org/officeDocument/2006/relationships">
+<p:sld xmlns:a="http://schemas.openxmlformats.org/drawingml/2006/main" xmlns:r="http://schemas.openxmlformats.org/officeDocument/2006/relationships" xmlns:p="http://schemas.openxmlformats.org/presentationml/2006/main">
   <p:cSld>
     <p:bg>
       <p:bgPr>
@@ -6908,7 +7113,14 @@
         <p:cNvGrpSpPr/>
         <p:nvPr/>
       </p:nvGrpSpPr>
-      <p:grpSpPr/>
+      <p:grpSpPr>
+        <a:xfrm>
+          <a:off x="0" y="0"/>
+          <a:ext cx="0" cy="0"/>
+          <a:chOff x="0" y="0"/>
+          <a:chExt cx="0" cy="0"/>
+        </a:xfrm>
+      </p:grpSpPr>
       <p:sp>
         <p:nvSpPr>
           <p:cNvPr id="2" name="TextBox 1"/>
@@ -7033,6 +7245,7 @@
           <a:lstStyle/>
           <a:p>
             <a:pPr algn="ctr"/>
+            <a:endParaRPr/>
           </a:p>
         </p:txBody>
       </p:sp>
@@ -7057,7 +7270,9 @@
             <a:spAutoFit/>
           </a:bodyPr>
           <a:lstStyle/>
-          <a:p/>
+          <a:p>
+            <a:endParaRPr/>
+          </a:p>
           <a:p>
             <a:pPr>
               <a:spcBef>
@@ -7183,7 +7398,7 @@
 </file>
 
 <file path=ppt/slides/slide9.xml><?xml version="1.0" encoding="utf-8"?>
-<p:sld xmlns:a="http://schemas.openxmlformats.org/drawingml/2006/main" xmlns:p="http://schemas.openxmlformats.org/presentationml/2006/main" xmlns:r="http://schemas.openxmlformats.org/officeDocument/2006/relationships">
+<p:sld xmlns:a="http://schemas.openxmlformats.org/drawingml/2006/main" xmlns:r="http://schemas.openxmlformats.org/officeDocument/2006/relationships" xmlns:p="http://schemas.openxmlformats.org/presentationml/2006/main">
   <p:cSld>
     <p:bg>
       <p:bgPr>
@@ -7199,7 +7414,14 @@
         <p:cNvGrpSpPr/>
         <p:nvPr/>
       </p:nvGrpSpPr>
-      <p:grpSpPr/>
+      <p:grpSpPr>
+        <a:xfrm>
+          <a:off x="0" y="0"/>
+          <a:ext cx="0" cy="0"/>
+          <a:chOff x="0" y="0"/>
+          <a:chExt cx="0" cy="0"/>
+        </a:xfrm>
+      </p:grpSpPr>
       <p:sp>
         <p:nvSpPr>
           <p:cNvPr id="2" name="TextBox 1"/>
@@ -7324,6 +7546,7 @@
           <a:lstStyle/>
           <a:p>
             <a:pPr algn="ctr"/>
+            <a:endParaRPr/>
           </a:p>
         </p:txBody>
       </p:sp>
@@ -7348,7 +7571,9 @@
             <a:spAutoFit/>
           </a:bodyPr>
           <a:lstStyle/>
-          <a:p/>
+          <a:p>
+            <a:endParaRPr/>
+          </a:p>
           <a:p>
             <a:pPr>
               <a:spcBef>

</xml_diff>